<commit_message>
Clean up pipeline, replace README, remove old draft files
</commit_message>
<xml_diff>
--- a/BehaviorShield_ePoster.pptx
+++ b/BehaviorShield_ePoster.pptx
@@ -914,7 +914,7 @@
         </p:blipFill>
         <p:spPr>
           <a:xfrm>
-            <a:off x="320040" y="164592"/>
+            <a:off x="304800" y="379476"/>
             <a:ext cx="566928" cy="566928"/>
           </a:xfrm>
           <a:prstGeom prst="rect">
@@ -930,7 +930,7 @@
         </p:nvSpPr>
         <p:spPr>
           <a:xfrm>
-            <a:off x="1005840" y="73152"/>
+            <a:off x="1005840" y="254193"/>
             <a:ext cx="10881360" cy="585216"/>
           </a:xfrm>
           <a:prstGeom prst="rect">
@@ -972,7 +972,7 @@
         </p:nvSpPr>
         <p:spPr>
           <a:xfrm>
-            <a:off x="1005840" y="640080"/>
+            <a:off x="1005840" y="905256"/>
             <a:ext cx="10881360" cy="219456"/>
           </a:xfrm>
           <a:prstGeom prst="rect">
@@ -1000,84 +1000,6 @@
               <a:t>BehaviorShield  —  Real XR Motion Capture  ·  Rigorous LOSO Evaluation  ·  SHAP Explainability</a:t>
             </a:r>
             <a:endParaRPr lang="en-US" sz="1250" dirty="0"/>
-          </a:p>
-        </p:txBody>
-      </p:sp>
-      <p:sp>
-        <p:nvSpPr>
-          <p:cNvPr id="6" name="Text 3"/>
-          <p:cNvSpPr/>
-          <p:nvPr/>
-        </p:nvSpPr>
-        <p:spPr>
-          <a:xfrm>
-            <a:off x="1005840" y="868680"/>
-            <a:ext cx="10881360" cy="182880"/>
-          </a:xfrm>
-          <a:prstGeom prst="rect">
-            <a:avLst/>
-          </a:prstGeom>
-          <a:noFill/>
-          <a:ln/>
-        </p:spPr>
-        <p:txBody>
-          <a:bodyPr wrap="square" lIns="0" tIns="0" rIns="0" bIns="0" rtlCol="0" anchor="ctr"/>
-          <a:lstStyle/>
-          <a:p>
-            <a:pPr marL="0" indent="0" algn="l">
-              <a:buNone/>
-            </a:pPr>
-            <a:r>
-              <a:rPr lang="en-US" sz="1050" dirty="0">
-                <a:solidFill>
-                  <a:srgbClr val="FFFFFF"/>
-                </a:solidFill>
-                <a:latin typeface="Calibri" pitchFamily="34" charset="0"/>
-                <a:ea typeface="Calibri" pitchFamily="34" charset="-122"/>
-                <a:cs typeface="Calibri" pitchFamily="34" charset="-120"/>
-              </a:rPr>
-              <a:t>Ritika Kalia¹   ·   Sudhakar Kumar¹   ·   Sunil K. Singh¹   ·   Samriti Sharma¹   ·   Kwok Tai Chui²   ·   Brij B. Gupta³</a:t>
-            </a:r>
-            <a:endParaRPr lang="en-US" sz="1050" dirty="0"/>
-          </a:p>
-        </p:txBody>
-      </p:sp>
-      <p:sp>
-        <p:nvSpPr>
-          <p:cNvPr id="7" name="Text 4"/>
-          <p:cNvSpPr/>
-          <p:nvPr/>
-        </p:nvSpPr>
-        <p:spPr>
-          <a:xfrm>
-            <a:off x="1005840" y="1060704"/>
-            <a:ext cx="10881360" cy="164592"/>
-          </a:xfrm>
-          <a:prstGeom prst="rect">
-            <a:avLst/>
-          </a:prstGeom>
-          <a:noFill/>
-          <a:ln/>
-        </p:spPr>
-        <p:txBody>
-          <a:bodyPr wrap="square" lIns="0" tIns="0" rIns="0" bIns="0" rtlCol="0" anchor="ctr"/>
-          <a:lstStyle/>
-          <a:p>
-            <a:pPr marL="0" indent="0" algn="l">
-              <a:buNone/>
-            </a:pPr>
-            <a:r>
-              <a:rPr lang="en-US" sz="870" dirty="0">
-                <a:solidFill>
-                  <a:srgbClr val="CADCFC"/>
-                </a:solidFill>
-                <a:latin typeface="Calibri" pitchFamily="34" charset="0"/>
-                <a:ea typeface="Calibri" pitchFamily="34" charset="-122"/>
-                <a:cs typeface="Calibri" pitchFamily="34" charset="-120"/>
-              </a:rPr>
-              <a:t>¹ Dept. of CSE, Chandigarh College of Engineering &amp; Technology, India     ² Hong Kong Metropolitan University, Hong Kong SAR, China     ³ Asia University, Taiwan &amp; VIZJA University, Poland</a:t>
-            </a:r>
-            <a:endParaRPr lang="en-US" sz="870" dirty="0"/>
           </a:p>
         </p:txBody>
       </p:sp>

</xml_diff>